<commit_message>
fix: invalidar cache del service worker v2 para forzar recarga UI
</commit_message>
<xml_diff>
--- a/docs/defensa/EcoAlerta-Defensa.pptx
+++ b/docs/defensa/EcoAlerta-Defensa.pptx
@@ -14,6 +14,7 @@
     <p:sldId id="262" r:id="rId8"/>
     <p:sldId id="263" r:id="rId9"/>
     <p:sldId id="264" r:id="rId10"/>
+    <p:sldId id="269" r:id="rId20"/>
     <p:sldId id="265" r:id="rId11"/>
     <p:sldId id="266" r:id="rId12"/>
     <p:sldId id="267" r:id="rId13"/>
@@ -807,10 +808,8 @@
           <a:lstStyle/>
           <a:p>
             <a:r>
-              <a:rPr lang="en-US" dirty="0"/>
               <a:t>Buenos días. Soy Erardo Aldana y presento mi Trabajo de Fin de Grado: EcoAlerta, una aplicación web colaborativa para el cuidado del medio ambiente, dirigida por el profesor Sánchez Romero.</a:t>
             </a:r>
-            <a:endParaRPr lang="en-US" dirty="0"/>
           </a:p>
         </p:txBody>
       </p:sp>
@@ -895,10 +894,8 @@
           <a:lstStyle/>
           <a:p>
             <a:r>
-              <a:rPr lang="en-US" dirty="0"/>
-              <a:t>Para validar, una pirámide de pruebas: unitarias e integración con Jest y Supertest, y end-to-end con Playwright sobre los tres flujos principales en tres navegadores, todo en GitHub Actions. Los resultados confirman la viabilidad: despliegue con un comando, cobertura del backend por encima del 60 % —salvo las ramas de error, que reconozco como limitación—, búsquedas geoespaciales por debajo del umbral, y todos los requisitos funcionales de prioridad alta cumplidos.</a:t>
-            </a:r>
-            <a:endParaRPr lang="en-US" dirty="0"/>
+              <a:t>Para validar, una pirámide de pruebas: unitarias e integración con Jest y Supertest, y end-to-end con Playwright en tres navegadores, todo en GitHub Actions. Los resultados confirman la viabilidad: despliegue con un comando, cobertura de backend por encima del 60 por ciento, geoespacial por debajo del umbral, y todos los requisitos de prioridad alta cumplidos y respaldados por pruebas.</a:t>
+            </a:r>
           </a:p>
         </p:txBody>
       </p:sp>
@@ -983,10 +980,8 @@
           <a:lstStyle/>
           <a:p>
             <a:r>
-              <a:rPr lang="en-US" dirty="0"/>
               <a:t>En conclusión: de los ocho objetivos, siete están plenamente cumplidos. El octavo, la validación de usabilidad con usuarios reales, queda parcial y lo reconozco como trabajo futuro inmediato. Más allá del enunciado, el resultado es de calidad cercana a producción: integración continua, audit log, segundo factor, capacidad offline. Y el diseño es reutilizable: el modelo de datos y el patrón de delegación se trasladan con pocos cambios a dominios como seguridad ciudadana o salud pública.</a:t>
             </a:r>
-            <a:endParaRPr lang="en-US" dirty="0"/>
           </a:p>
         </p:txBody>
       </p:sp>
@@ -1071,10 +1066,8 @@
           <a:lstStyle/>
           <a:p>
             <a:r>
-              <a:rPr lang="en-US" dirty="0"/>
-              <a:t>Soy consciente de los límites: la cobertura de ramas se queda en el 39 %, el envío de email no se ha probado contra un servidor real, y la usabilidad con usuarios reales queda pendiente. Como trabajo futuro veo subir cobertura, desplegar en cloud con HTTPS, una app nativa con React Native, asignación automática por intersección geoespacial con la jurisdicción, y clasificación automática de la foto por visión por computador.</a:t>
-            </a:r>
-            <a:endParaRPr lang="en-US" dirty="0"/>
+              <a:t>Soy consciente de los límites: la cobertura de ramas se queda en el 39 por ciento, el email no se ha probado contra un servidor real, y la usabilidad con usuarios queda pendiente. Como trabajo futuro: subir cobertura, desplegar en cloud con HTTPS, una app nativa con React Native sobre la misma API, asignación automática por jurisdicción geoespacial, y clasificación de la foto por visión por computador.</a:t>
+            </a:r>
           </a:p>
         </p:txBody>
       </p:sp>
@@ -1159,10 +1152,8 @@
           <a:lstStyle/>
           <a:p>
             <a:r>
-              <a:rPr lang="en-US" dirty="0"/>
-              <a:t>Cierro con la idea que me llevo del proyecto: combinar especificación, IA y revisión rigurosa es, probablemente, cómo va a trabajar buena parte de la industria. Y la diferencia no la marca delegar, sino dirigir bien. Gracias por su atención; quedo a su disposición para las preguntas.</a:t>
-            </a:r>
-            <a:endParaRPr lang="en-US" dirty="0"/>
+              <a:t>Cierro con la idea que me llevo: combinar especificación, IA y revisión rigurosa es, probablemente, cómo va a trabajar buena parte de la industria. Y la diferencia no la marca delegar, sino dirigir bien. Gracias por su atención; quedo a su disposición para las preguntas.</a:t>
+            </a:r>
           </a:p>
         </p:txBody>
       </p:sp>
@@ -1247,10 +1238,8 @@
           <a:lstStyle/>
           <a:p>
             <a:r>
-              <a:rPr lang="en-US" dirty="0"/>
-              <a:t>España vive una década complicada en lo medioambiental: más de diez mil incendios al año, el SEPRONA tramita más de ciento treinta mil actuaciones. A la vez, casi todos los hogares tienen un móvil con cámara y GPS. El problema es que los canales tradicionales no aprovechan ese flujo ni devuelven seguimiento al ciudadano que denuncia.</a:t>
-            </a:r>
-            <a:endParaRPr lang="en-US" dirty="0"/>
+              <a:t>España tiene una presión medioambiental enorme: más de diez mil incendios al año y más de ciento treinta mil actuaciones del SEPRONA. Y a la vez, casi todos los hogares tienen un móvil con cámara y GPS. El problema es que los canales tradicionales no aprovechan ese flujo ni devuelven seguimiento al ciudadano que denuncia.</a:t>
+            </a:r>
           </a:p>
         </p:txBody>
       </p:sp>
@@ -1335,10 +1324,8 @@
           <a:lstStyle/>
           <a:p>
             <a:r>
-              <a:rPr lang="en-US" dirty="0"/>
-              <a:t>Analicé cinco aplicaciones cívicas de referencia. Todas cubren parte del problema, pero ninguna combina a la vez cuatro cosas: reporte geolocalizado con foto, delegación a la entidad responsable correcta —que no siempre es el ayuntamiento, puede ser SEPRONA o bomberos—, niveles de severidad ligados al impacto, y un componente social que ayude a priorizar. Ese hueco es lo que tapa EcoAlerta.</a:t>
-            </a:r>
-            <a:endParaRPr lang="en-US" dirty="0"/>
+              <a:t>Analicé cinco aplicaciones cívicas de referencia. Todas cubren parte del problema, pero ninguna combina a la vez cuatro cosas: reporte geolocalizado con foto, delegación a la entidad responsable correcta —que no siempre es el ayuntamiento, puede ser SEPRONA o bomberos—, niveles de severidad, y un componente social que ayude a priorizar. Ese hueco es lo que tapa EcoAlerta.</a:t>
+            </a:r>
           </a:p>
         </p:txBody>
       </p:sp>
@@ -1423,10 +1410,8 @@
           <a:lstStyle/>
           <a:p>
             <a:r>
-              <a:rPr lang="en-US" dirty="0"/>
-              <a:t>El objetivo general: diseñar, implementar y validar una PWA que facilite el reporte geolocalizado y su delegación automatizada, con flujo de estados trazable y componente social. Se desglosa en ocho objetivos específicos, desde el análisis del estado del arte hasta la documentación reproducible y un estudio de modelo de negocio.</a:t>
-            </a:r>
-            <a:endParaRPr lang="en-US" dirty="0"/>
+              <a:t>El objetivo general: diseñar, implementar y validar una PWA para el reporte geolocalizado y su delegación automatizada, con flujo de estados trazable y componente social. Se desglosa en ocho objetivos específicos, del estado del arte a la documentación reproducible y un estudio de modelo de negocio.</a:t>
+            </a:r>
           </a:p>
         </p:txBody>
       </p:sp>
@@ -1511,10 +1496,8 @@
           <a:lstStyle/>
           <a:p>
             <a:r>
-              <a:rPr lang="en-US" dirty="0"/>
-              <a:t>La arquitectura son tres capas desplegadas con Docker Compose. En el frontend, una SPA en React 18 con Tailwind y Leaflet sobre OpenStreetMap, instalable como PWA y con soporte offline. En medio, una API REST en Node 20 con Express, 35 endpoints documentados con Swagger. Y abajo, PostgreSQL 16 con PostGIS. Todo el sistema se levanta reproducible con un solo comando.</a:t>
-            </a:r>
-            <a:endParaRPr lang="en-US" dirty="0"/>
+              <a:t>La arquitectura son tres capas en Docker Compose. Frontend: una SPA en React 18 con Tailwind y Leaflet sobre OpenStreetMap, instalable como PWA y con soporte offline. En medio, una API REST en Node 20 con Express, documentada con Swagger. Y abajo, PostgreSQL 16 con PostGIS. Todo se levanta reproducible con un solo comando.</a:t>
+            </a:r>
           </a:p>
         </p:txBody>
       </p:sp>
@@ -1599,10 +1582,8 @@
           <a:lstStyle/>
           <a:p>
             <a:r>
-              <a:rPr lang="en-US" dirty="0"/>
-              <a:t>El modelo tiene trece entidades: incidencias, fotos, comentarios, votos, seguimientos, historial de estados, notificaciones y un audit log de seguridad. El reto técnico más interesante fue el rendimiento geoespacial: la consulta de incidencias en un radio se degrada muy rápido sin índice. Usando ST_DWithin con un índice GIST, PostgreSQL descarta filas antes de calcular distancias, y mantengo las búsquedas en un radio de cinco kilómetros por debajo de 500 milisegundos. De hecho el agente de IA proponía ST_Distance con WHERE, que es ineficiente; lo cambié tras revisar la documentación de PostGIS.</a:t>
-            </a:r>
-            <a:endParaRPr lang="en-US" dirty="0"/>
+              <a:t>El modelo tiene trece entidades en cuatro subsistemas: identidad y seguridad, catálogos, núcleo de incidencias e interacción social. El reto más interesante fue el rendimiento geoespacial: la consulta de incidencias en un radio se degrada muy rápido sin índice. Con ST_DWithin sobre un índice GIST, PostgreSQL descarta filas antes de calcular distancias, y mantengo las búsquedas en cinco kilómetros por debajo de 500 milisegundos, incluso con miles de incidencias.</a:t>
+            </a:r>
           </a:p>
         </p:txBody>
       </p:sp>
@@ -1687,10 +1668,8 @@
           <a:lstStyle/>
           <a:p>
             <a:r>
-              <a:rPr lang="en-US" dirty="0"/>
-              <a:t>Quise llevar la seguridad a un nivel cercano a producción. JWT dual: access corto de quince minutos y refresh de siete días que rota en cada uso. Segundo factor TOTP, con el secreto cifrado en base de datos con AES-256, de modo que un volcado de la base no compromete el 2FA. Además rate limiting, captcha invisible de Cloudflare, audit log y bcrypt. Nada de esto era obligatorio, pero hace el sistema mucho más realista.</a:t>
-            </a:r>
-            <a:endParaRPr lang="en-US" dirty="0"/>
+              <a:t>Llevé la seguridad a un nivel cercano a producción. JWT dual: un access corto y un refresh que rota en cada uso, renovado sin que el usuario vea errores. Segundo factor TOTP, con el secreto cifrado en base de datos con AES-256, de modo que un volcado de la base no compromete el 2FA. Más rate limiting, captcha invisible de Cloudflare y audit log. Nada de esto exigía el enunciado, pero hace el sistema mucho más realista.</a:t>
+            </a:r>
           </a:p>
         </p:txBody>
       </p:sp>
@@ -1775,10 +1754,8 @@
           <a:lstStyle/>
           <a:p>
             <a:r>
-              <a:rPr lang="en-US" dirty="0"/>
-              <a:t>Desarrollé en seis sprints de una semana aplicando Spec-Driven Development con SpecKit en el IDE Google Antigravity. Primero escribo la especificación del sprint con criterios de aceptación, después el agente genera código a partir de ella, lo reviso, ejecuto las pruebas, depuro lo que hace mal, y hago commit. El uso de IA está declarado de forma explícita y deja trazas auditables. La diferencia no la marca delegar, sino dirigir bien.</a:t>
-            </a:r>
-            <a:endParaRPr lang="en-US" dirty="0"/>
+              <a:t>Desarrollé en seis sprints de una semana con Spec-Driven Development y SpecKit en el IDE Antigravity. El flujo: especifico el sprint con criterios de aceptación, el agente genera código, lo reviso, ejecuto pruebas, depuro y hago commit. El uso de IA está declarado y deja trazas auditables en el repositorio. La diferencia no la marca delegar, sino dirigir bien.</a:t>
+            </a:r>
           </a:p>
         </p:txBody>
       </p:sp>
@@ -1863,10 +1840,8 @@
           <a:lstStyle/>
           <a:p>
             <a:r>
-              <a:rPr lang="en-US" dirty="0"/>
-              <a:t>Así se ve en funcionamiento. El mapa público, centrado en Alicante, con marcadores coloreados por severidad. El ciudadano reporta en menos de un minuto: ubicación, categoría entre doce opciones, severidad y foto. En el detalle se ven fotos, votos, comentarios e historial de estados. Y el administrador gestiona desde un panel con estadísticas y delega cada incidencia a la entidad responsable.</a:t>
-            </a:r>
-            <a:endParaRPr lang="en-US" dirty="0"/>
+              <a:t>[Mientras corre el vídeo, frases sueltas, no locutar todo] Así funciona. El ciudadano reporta desde el móvil en menos de un minuto: ubicación, categoría entre doce, severidad y foto. La incidencia aparece en el mapa, coloreada por severidad. Y desde el panel, el administrador la valida, cambia su estado y la delega a la entidad responsable, que recibe la notificación. [Si fallara el vídeo: salto a la diapositiva oculta de capturas.]</a:t>
+            </a:r>
           </a:p>
         </p:txBody>
       </p:sp>
@@ -5166,6 +5141,551 @@
 </p:sld>
 </file>
 
+<file path=ppt/slides/slide14.xml><?xml version="1.0" encoding="utf-8"?>
+<p:sld xmlns:a="http://schemas.openxmlformats.org/drawingml/2006/main" xmlns:p="http://schemas.openxmlformats.org/presentationml/2006/main" xmlns:r="http://schemas.openxmlformats.org/officeDocument/2006/relationships" show="0">
+  <p:cSld>
+    <p:spTree>
+      <p:nvGrpSpPr>
+        <p:cNvPr id="1" name=""/>
+        <p:cNvGrpSpPr/>
+        <p:nvPr/>
+      </p:nvGrpSpPr>
+      <p:grpSpPr/>
+      <p:sp>
+        <p:nvSpPr>
+          <p:cNvPr id="2" name="Shape 0"/>
+          <p:cNvSpPr/>
+          <p:nvPr/>
+        </p:nvSpPr>
+        <p:spPr>
+          <a:xfrm>
+            <a:off x="548640" y="475488"/>
+            <a:ext cx="146304" cy="475488"/>
+          </a:xfrm>
+          <a:prstGeom prst="roundRect">
+            <a:avLst>
+              <a:gd name="adj" fmla="val 31250"/>
+            </a:avLst>
+          </a:prstGeom>
+          <a:solidFill>
+            <a:srgbClr val="1FA463"/>
+          </a:solidFill>
+          <a:ln/>
+        </p:spPr>
+      </p:sp>
+      <p:sp>
+        <p:nvSpPr>
+          <p:cNvPr id="3" name="Text 1"/>
+          <p:cNvSpPr/>
+          <p:nvPr/>
+        </p:nvSpPr>
+        <p:spPr>
+          <a:xfrm>
+            <a:off x="841248" y="411480"/>
+            <a:ext cx="10789920" cy="640080"/>
+          </a:xfrm>
+          <a:prstGeom prst="rect">
+            <a:avLst/>
+          </a:prstGeom>
+          <a:noFill/>
+          <a:ln/>
+        </p:spPr>
+        <p:txBody>
+          <a:bodyPr wrap="square" lIns="0" tIns="0" rIns="0" bIns="0" rtlCol="0" anchor="ctr"/>
+          <a:lstStyle/>
+          <a:p>
+            <a:pPr indent="0" marL="0">
+              <a:buNone/>
+            </a:pPr>
+            <a:r>
+              <a:rPr lang="en-US" sz="2800" b="1" dirty="0">
+                <a:solidFill>
+                  <a:srgbClr val="0E3A36"/>
+                </a:solidFill>
+                <a:latin typeface="Calibri" pitchFamily="34" charset="0"/>
+                <a:ea typeface="Calibri" pitchFamily="34" charset="-122"/>
+                <a:cs typeface="Calibri" pitchFamily="34" charset="-120"/>
+              </a:rPr>
+              <a:t>EcoAlerta en funcionamiento</a:t>
+            </a:r>
+            <a:endParaRPr lang="en-US" sz="2800" dirty="0"/>
+          </a:p>
+        </p:txBody>
+      </p:sp>
+      <p:sp>
+        <p:nvSpPr>
+          <p:cNvPr id="4" name="Text 2"/>
+          <p:cNvSpPr/>
+          <p:nvPr/>
+        </p:nvSpPr>
+        <p:spPr>
+          <a:xfrm>
+            <a:off x="548640" y="6437376"/>
+            <a:ext cx="5486400" cy="274320"/>
+          </a:xfrm>
+          <a:prstGeom prst="rect">
+            <a:avLst/>
+          </a:prstGeom>
+          <a:noFill/>
+          <a:ln/>
+        </p:spPr>
+        <p:txBody>
+          <a:bodyPr wrap="square" rtlCol="0" anchor="ctr"/>
+          <a:lstStyle/>
+          <a:p>
+            <a:pPr indent="0" marL="0">
+              <a:buNone/>
+            </a:pPr>
+            <a:r>
+              <a:rPr lang="en-US" sz="900" dirty="0">
+                <a:solidFill>
+                  <a:srgbClr val="5E6E6B"/>
+                </a:solidFill>
+                <a:latin typeface="Calibri" pitchFamily="34" charset="0"/>
+                <a:ea typeface="Calibri" pitchFamily="34" charset="-122"/>
+                <a:cs typeface="Calibri" pitchFamily="34" charset="-120"/>
+              </a:rPr>
+              <a:t>EcoAlerta · Trabajo Fin de Grado</a:t>
+            </a:r>
+            <a:endParaRPr lang="en-US" sz="900" dirty="0"/>
+          </a:p>
+        </p:txBody>
+      </p:sp>
+      <p:sp>
+        <p:nvSpPr>
+          <p:cNvPr id="5" name="Text 3"/>
+          <p:cNvSpPr/>
+          <p:nvPr/>
+        </p:nvSpPr>
+        <p:spPr>
+          <a:xfrm>
+            <a:off x="10725912" y="6437376"/>
+            <a:ext cx="914400" cy="274320"/>
+          </a:xfrm>
+          <a:prstGeom prst="rect">
+            <a:avLst/>
+          </a:prstGeom>
+          <a:noFill/>
+          <a:ln/>
+        </p:spPr>
+        <p:txBody>
+          <a:bodyPr wrap="square" rtlCol="0" anchor="ctr"/>
+          <a:lstStyle/>
+          <a:p>
+            <a:pPr algn="r" indent="0" marL="0">
+              <a:buNone/>
+            </a:pPr>
+            <a:r>
+              <a:rPr lang="en-US" sz="900" dirty="0">
+                <a:solidFill>
+                  <a:srgbClr val="5E6E6B"/>
+                </a:solidFill>
+                <a:latin typeface="Calibri" pitchFamily="34" charset="0"/>
+                <a:ea typeface="Calibri" pitchFamily="34" charset="-122"/>
+                <a:cs typeface="Calibri" pitchFamily="34" charset="-120"/>
+              </a:rPr>
+              <a:t>9 / 13</a:t>
+            </a:r>
+            <a:endParaRPr lang="en-US" sz="900" dirty="0"/>
+          </a:p>
+        </p:txBody>
+      </p:sp>
+      <p:sp>
+        <p:nvSpPr>
+          <p:cNvPr id="6" name="Shape 4"/>
+          <p:cNvSpPr/>
+          <p:nvPr/>
+        </p:nvSpPr>
+        <p:spPr>
+          <a:xfrm>
+            <a:off x="548640" y="1371600"/>
+            <a:ext cx="5458968" cy="2331720"/>
+          </a:xfrm>
+          <a:prstGeom prst="roundRect">
+            <a:avLst>
+              <a:gd name="adj" fmla="val 3137"/>
+            </a:avLst>
+          </a:prstGeom>
+          <a:solidFill>
+            <a:srgbClr val="FFFFFF"/>
+          </a:solidFill>
+          <a:ln w="12700">
+            <a:solidFill>
+              <a:srgbClr val="E0EBE7"/>
+            </a:solidFill>
+            <a:prstDash val="solid"/>
+          </a:ln>
+          <a:effectLst>
+            <a:outerShdw sx="100000" sy="100000" kx="0" ky="0" algn="bl" rotWithShape="0" blurRad="88900" dist="38100" dir="8100000">
+              <a:srgbClr val="0E3A36">
+                <a:alpha val="16000"/>
+              </a:srgbClr>
+            </a:outerShdw>
+          </a:effectLst>
+        </p:spPr>
+      </p:sp>
+      <p:pic>
+        <p:nvPicPr>
+          <p:cNvPr id="7" name="Image 0" descr="/tmp/deck/assets/ui-mapa-principal.png">    </p:cNvPr>
+          <p:cNvPicPr>
+            <a:picLocks noChangeAspect="1"/>
+          </p:cNvPicPr>
+          <p:nvPr/>
+        </p:nvPicPr>
+        <p:blipFill>
+          <a:blip r:embed="rId2"/>
+          <a:stretch>
+            <a:fillRect/>
+          </a:stretch>
+        </p:blipFill>
+        <p:spPr>
+          <a:xfrm>
+            <a:off x="1426077" y="1481328"/>
+            <a:ext cx="3704095" cy="1828800"/>
+          </a:xfrm>
+          <a:prstGeom prst="rect">
+            <a:avLst/>
+          </a:prstGeom>
+        </p:spPr>
+      </p:pic>
+      <p:sp>
+        <p:nvSpPr>
+          <p:cNvPr id="8" name="Text 5"/>
+          <p:cNvSpPr/>
+          <p:nvPr/>
+        </p:nvSpPr>
+        <p:spPr>
+          <a:xfrm>
+            <a:off x="658368" y="3319272"/>
+            <a:ext cx="5239512" cy="329184"/>
+          </a:xfrm>
+          <a:prstGeom prst="rect">
+            <a:avLst/>
+          </a:prstGeom>
+          <a:noFill/>
+          <a:ln/>
+        </p:spPr>
+        <p:txBody>
+          <a:bodyPr wrap="square" rtlCol="0" anchor="ctr"/>
+          <a:lstStyle/>
+          <a:p>
+            <a:pPr algn="ctr" indent="0" marL="0">
+              <a:buNone/>
+            </a:pPr>
+            <a:r>
+              <a:rPr lang="en-US" sz="1200" b="1" dirty="0">
+                <a:solidFill>
+                  <a:srgbClr val="0E3A36"/>
+                </a:solidFill>
+                <a:latin typeface="Calibri" pitchFamily="34" charset="0"/>
+                <a:ea typeface="Calibri" pitchFamily="34" charset="-122"/>
+                <a:cs typeface="Calibri" pitchFamily="34" charset="-120"/>
+              </a:rPr>
+              <a:t>Mapa público con marcadores por severidad</a:t>
+            </a:r>
+            <a:endParaRPr lang="en-US" sz="1200" dirty="0"/>
+          </a:p>
+        </p:txBody>
+      </p:sp>
+      <p:sp>
+        <p:nvSpPr>
+          <p:cNvPr id="9" name="Shape 6"/>
+          <p:cNvSpPr/>
+          <p:nvPr/>
+        </p:nvSpPr>
+        <p:spPr>
+          <a:xfrm>
+            <a:off x="6537960" y="1371600"/>
+            <a:ext cx="5458968" cy="2331720"/>
+          </a:xfrm>
+          <a:prstGeom prst="roundRect">
+            <a:avLst>
+              <a:gd name="adj" fmla="val 3137"/>
+            </a:avLst>
+          </a:prstGeom>
+          <a:solidFill>
+            <a:srgbClr val="FFFFFF"/>
+          </a:solidFill>
+          <a:ln w="12700">
+            <a:solidFill>
+              <a:srgbClr val="E0EBE7"/>
+            </a:solidFill>
+            <a:prstDash val="solid"/>
+          </a:ln>
+          <a:effectLst>
+            <a:outerShdw sx="100000" sy="100000" kx="0" ky="0" algn="bl" rotWithShape="0" blurRad="88900" dist="38100" dir="8100000">
+              <a:srgbClr val="0E3A36">
+                <a:alpha val="16000"/>
+              </a:srgbClr>
+            </a:outerShdw>
+          </a:effectLst>
+        </p:spPr>
+      </p:sp>
+      <p:pic>
+        <p:nvPicPr>
+          <p:cNvPr id="10" name="Image 1" descr="/tmp/deck/assets/ui-crear-incidencia.png">    </p:cNvPr>
+          <p:cNvPicPr>
+            <a:picLocks noChangeAspect="1"/>
+          </p:cNvPicPr>
+          <p:nvPr/>
+        </p:nvPicPr>
+        <p:blipFill>
+          <a:blip r:embed="rId3"/>
+          <a:stretch>
+            <a:fillRect/>
+          </a:stretch>
+        </p:blipFill>
+        <p:spPr>
+          <a:xfrm>
+            <a:off x="7412435" y="1481328"/>
+            <a:ext cx="3710018" cy="1828800"/>
+          </a:xfrm>
+          <a:prstGeom prst="rect">
+            <a:avLst/>
+          </a:prstGeom>
+        </p:spPr>
+      </p:pic>
+      <p:sp>
+        <p:nvSpPr>
+          <p:cNvPr id="11" name="Text 7"/>
+          <p:cNvSpPr/>
+          <p:nvPr/>
+        </p:nvSpPr>
+        <p:spPr>
+          <a:xfrm>
+            <a:off x="6647688" y="3319272"/>
+            <a:ext cx="5239512" cy="329184"/>
+          </a:xfrm>
+          <a:prstGeom prst="rect">
+            <a:avLst/>
+          </a:prstGeom>
+          <a:noFill/>
+          <a:ln/>
+        </p:spPr>
+        <p:txBody>
+          <a:bodyPr wrap="square" rtlCol="0" anchor="ctr"/>
+          <a:lstStyle/>
+          <a:p>
+            <a:pPr algn="ctr" indent="0" marL="0">
+              <a:buNone/>
+            </a:pPr>
+            <a:r>
+              <a:rPr lang="en-US" sz="1200" b="1" dirty="0">
+                <a:solidFill>
+                  <a:srgbClr val="0E3A36"/>
+                </a:solidFill>
+                <a:latin typeface="Calibri" pitchFamily="34" charset="0"/>
+                <a:ea typeface="Calibri" pitchFamily="34" charset="-122"/>
+                <a:cs typeface="Calibri" pitchFamily="34" charset="-120"/>
+              </a:rPr>
+              <a:t>Reporte: categoría, severidad, foto y GPS</a:t>
+            </a:r>
+            <a:endParaRPr lang="en-US" sz="1200" dirty="0"/>
+          </a:p>
+        </p:txBody>
+      </p:sp>
+      <p:sp>
+        <p:nvSpPr>
+          <p:cNvPr id="12" name="Shape 8"/>
+          <p:cNvSpPr/>
+          <p:nvPr/>
+        </p:nvSpPr>
+        <p:spPr>
+          <a:xfrm>
+            <a:off x="548640" y="3995928"/>
+            <a:ext cx="5458968" cy="2331720"/>
+          </a:xfrm>
+          <a:prstGeom prst="roundRect">
+            <a:avLst>
+              <a:gd name="adj" fmla="val 3137"/>
+            </a:avLst>
+          </a:prstGeom>
+          <a:solidFill>
+            <a:srgbClr val="FFFFFF"/>
+          </a:solidFill>
+          <a:ln w="12700">
+            <a:solidFill>
+              <a:srgbClr val="E0EBE7"/>
+            </a:solidFill>
+            <a:prstDash val="solid"/>
+          </a:ln>
+          <a:effectLst>
+            <a:outerShdw sx="100000" sy="100000" kx="0" ky="0" algn="bl" rotWithShape="0" blurRad="88900" dist="38100" dir="8100000">
+              <a:srgbClr val="0E3A36">
+                <a:alpha val="16000"/>
+              </a:srgbClr>
+            </a:outerShdw>
+          </a:effectLst>
+        </p:spPr>
+      </p:sp>
+      <p:pic>
+        <p:nvPicPr>
+          <p:cNvPr id="13" name="Image 2" descr="/tmp/deck/assets/ui-detalle.png">    </p:cNvPr>
+          <p:cNvPicPr>
+            <a:picLocks noChangeAspect="1"/>
+          </p:cNvPicPr>
+          <p:nvPr/>
+        </p:nvPicPr>
+        <p:blipFill>
+          <a:blip r:embed="rId4"/>
+          <a:stretch>
+            <a:fillRect/>
+          </a:stretch>
+        </p:blipFill>
+        <p:spPr>
+          <a:xfrm>
+            <a:off x="1422144" y="4105656"/>
+            <a:ext cx="3711959" cy="1828800"/>
+          </a:xfrm>
+          <a:prstGeom prst="rect">
+            <a:avLst/>
+          </a:prstGeom>
+        </p:spPr>
+      </p:pic>
+      <p:sp>
+        <p:nvSpPr>
+          <p:cNvPr id="14" name="Text 9"/>
+          <p:cNvSpPr/>
+          <p:nvPr/>
+        </p:nvSpPr>
+        <p:spPr>
+          <a:xfrm>
+            <a:off x="658368" y="5943600"/>
+            <a:ext cx="5239512" cy="329184"/>
+          </a:xfrm>
+          <a:prstGeom prst="rect">
+            <a:avLst/>
+          </a:prstGeom>
+          <a:noFill/>
+          <a:ln/>
+        </p:spPr>
+        <p:txBody>
+          <a:bodyPr wrap="square" rtlCol="0" anchor="ctr"/>
+          <a:lstStyle/>
+          <a:p>
+            <a:pPr algn="ctr" indent="0" marL="0">
+              <a:buNone/>
+            </a:pPr>
+            <a:r>
+              <a:rPr lang="en-US" sz="1200" b="1" dirty="0">
+                <a:solidFill>
+                  <a:srgbClr val="0E3A36"/>
+                </a:solidFill>
+                <a:latin typeface="Calibri" pitchFamily="34" charset="0"/>
+                <a:ea typeface="Calibri" pitchFamily="34" charset="-122"/>
+                <a:cs typeface="Calibri" pitchFamily="34" charset="-120"/>
+              </a:rPr>
+              <a:t>Detalle: fotos, votos, comentarios e historial</a:t>
+            </a:r>
+            <a:endParaRPr lang="en-US" sz="1200" dirty="0"/>
+          </a:p>
+        </p:txBody>
+      </p:sp>
+      <p:sp>
+        <p:nvSpPr>
+          <p:cNvPr id="15" name="Shape 10"/>
+          <p:cNvSpPr/>
+          <p:nvPr/>
+        </p:nvSpPr>
+        <p:spPr>
+          <a:xfrm>
+            <a:off x="6537960" y="3995928"/>
+            <a:ext cx="5458968" cy="2331720"/>
+          </a:xfrm>
+          <a:prstGeom prst="roundRect">
+            <a:avLst>
+              <a:gd name="adj" fmla="val 3137"/>
+            </a:avLst>
+          </a:prstGeom>
+          <a:solidFill>
+            <a:srgbClr val="FFFFFF"/>
+          </a:solidFill>
+          <a:ln w="12700">
+            <a:solidFill>
+              <a:srgbClr val="E0EBE7"/>
+            </a:solidFill>
+            <a:prstDash val="solid"/>
+          </a:ln>
+          <a:effectLst>
+            <a:outerShdw sx="100000" sy="100000" kx="0" ky="0" algn="bl" rotWithShape="0" blurRad="88900" dist="38100" dir="8100000">
+              <a:srgbClr val="0E3A36">
+                <a:alpha val="16000"/>
+              </a:srgbClr>
+            </a:outerShdw>
+          </a:effectLst>
+        </p:spPr>
+      </p:sp>
+      <p:pic>
+        <p:nvPicPr>
+          <p:cNvPr id="16" name="Image 3" descr="/tmp/deck/assets/manual-admin-dashboard.png">    </p:cNvPr>
+          <p:cNvPicPr>
+            <a:picLocks noChangeAspect="1"/>
+          </p:cNvPicPr>
+          <p:nvPr/>
+        </p:nvPicPr>
+        <p:blipFill>
+          <a:blip r:embed="rId5"/>
+          <a:stretch>
+            <a:fillRect/>
+          </a:stretch>
+        </p:blipFill>
+        <p:spPr>
+          <a:xfrm>
+            <a:off x="7786987" y="4105656"/>
+            <a:ext cx="2960914" cy="1828800"/>
+          </a:xfrm>
+          <a:prstGeom prst="rect">
+            <a:avLst/>
+          </a:prstGeom>
+        </p:spPr>
+      </p:pic>
+      <p:sp>
+        <p:nvSpPr>
+          <p:cNvPr id="17" name="Text 11"/>
+          <p:cNvSpPr/>
+          <p:nvPr/>
+        </p:nvSpPr>
+        <p:spPr>
+          <a:xfrm>
+            <a:off x="6647688" y="5943600"/>
+            <a:ext cx="5239512" cy="329184"/>
+          </a:xfrm>
+          <a:prstGeom prst="rect">
+            <a:avLst/>
+          </a:prstGeom>
+          <a:noFill/>
+          <a:ln/>
+        </p:spPr>
+        <p:txBody>
+          <a:bodyPr wrap="square" rtlCol="0" anchor="ctr"/>
+          <a:lstStyle/>
+          <a:p>
+            <a:pPr algn="ctr" indent="0" marL="0">
+              <a:buNone/>
+            </a:pPr>
+            <a:r>
+              <a:rPr lang="en-US" sz="1200" b="1" dirty="0">
+                <a:solidFill>
+                  <a:srgbClr val="0E3A36"/>
+                </a:solidFill>
+                <a:latin typeface="Calibri" pitchFamily="34" charset="0"/>
+                <a:ea typeface="Calibri" pitchFamily="34" charset="-122"/>
+                <a:cs typeface="Calibri" pitchFamily="34" charset="-120"/>
+              </a:rPr>
+              <a:t>Panel de administración con estadísticas</a:t>
+            </a:r>
+            <a:endParaRPr lang="en-US" sz="1200" dirty="0"/>
+          </a:p>
+        </p:txBody>
+      </p:sp>
+    </p:spTree>
+  </p:cSld>
+  <p:clrMapOvr>
+    <a:masterClrMapping/>
+  </p:clrMapOvr>
+</p:sld>
+</file>
+
 <file path=ppt/slides/slide2.xml><?xml version="1.0" encoding="utf-8"?>
 <p:sld xmlns:a="http://schemas.openxmlformats.org/drawingml/2006/main" xmlns:r="http://schemas.openxmlformats.org/officeDocument/2006/relationships" xmlns:p="http://schemas.openxmlformats.org/presentationml/2006/main">
   <p:cSld name="Slide 2">
@@ -14742,6 +15262,10 @@
           </a:solidFill>
           <a:ln/>
         </p:spPr>
+        <p:txBody>
+          <a:bodyPr/>
+          <a:p/>
+        </p:txBody>
       </p:sp>
       <p:sp>
         <p:nvSpPr>
@@ -14862,389 +15386,120 @@
       </p:sp>
       <p:sp>
         <p:nvSpPr>
-          <p:cNvPr id="6" name="Shape 4"/>
-          <p:cNvSpPr/>
-          <p:nvPr/>
-        </p:nvSpPr>
-        <p:spPr>
-          <a:xfrm>
-            <a:off x="548640" y="1371600"/>
-            <a:ext cx="5458968" cy="2331720"/>
+          <p:cNvPr id="6" name="Rounded Rectangle 5"/>
+          <p:cNvSpPr/>
+          <p:nvPr/>
+        </p:nvSpPr>
+        <p:spPr>
+          <a:xfrm>
+            <a:off x="2194560" y="1508760"/>
+            <a:ext cx="7799831" cy="4389120"/>
           </a:xfrm>
           <a:prstGeom prst="roundRect">
-            <a:avLst>
-              <a:gd name="adj" fmla="val 3137"/>
-            </a:avLst>
+            <a:avLst/>
           </a:prstGeom>
           <a:solidFill>
-            <a:srgbClr val="FFFFFF"/>
+            <a:srgbClr val="F0F7F4"/>
           </a:solidFill>
-          <a:ln w="12700">
+          <a:ln w="28575">
             <a:solidFill>
-              <a:srgbClr val="E0EBE7"/>
+              <a:srgbClr val="0A7D5A"/>
             </a:solidFill>
-            <a:prstDash val="solid"/>
+            <a:prstDash val="dash"/>
           </a:ln>
-          <a:effectLst>
-            <a:outerShdw sx="100000" sy="100000" kx="0" ky="0" algn="bl" rotWithShape="0" blurRad="88900" dist="38100" dir="8100000">
-              <a:srgbClr val="0E3A36">
-                <a:alpha val="16000"/>
-              </a:srgbClr>
-            </a:outerShdw>
-          </a:effectLst>
-        </p:spPr>
-      </p:sp>
-      <p:pic>
-        <p:nvPicPr>
-          <p:cNvPr id="7" name="Image 0" descr="/tmp/deck/assets/ui-mapa-principal.png">    </p:cNvPr>
-          <p:cNvPicPr>
-            <a:picLocks noChangeAspect="1"/>
-          </p:cNvPicPr>
-          <p:nvPr/>
-        </p:nvPicPr>
-        <p:blipFill>
-          <a:blip r:embed="rId1"/>
-          <a:stretch>
-            <a:fillRect/>
-          </a:stretch>
-        </p:blipFill>
-        <p:spPr>
-          <a:xfrm>
-            <a:off x="1426077" y="1481328"/>
-            <a:ext cx="3704095" cy="1828800"/>
-          </a:xfrm>
-          <a:prstGeom prst="rect">
-            <a:avLst/>
-          </a:prstGeom>
-        </p:spPr>
-      </p:pic>
-      <p:sp>
-        <p:nvSpPr>
-          <p:cNvPr id="8" name="Text 5"/>
-          <p:cNvSpPr/>
-          <p:nvPr/>
-        </p:nvSpPr>
-        <p:spPr>
-          <a:xfrm>
-            <a:off x="658368" y="3319272"/>
-            <a:ext cx="5239512" cy="329184"/>
+          <a:effectLst/>
+        </p:spPr>
+        <p:style>
+          <a:lnRef idx="1">
+            <a:schemeClr val="accent1"/>
+          </a:lnRef>
+          <a:fillRef idx="3">
+            <a:schemeClr val="accent1"/>
+          </a:fillRef>
+          <a:effectRef idx="2">
+            <a:schemeClr val="accent1"/>
+          </a:effectRef>
+          <a:fontRef idx="minor">
+            <a:schemeClr val="lt1"/>
+          </a:fontRef>
+        </p:style>
+        <p:txBody>
+          <a:bodyPr rtlCol="0" anchor="ctr" wrap="square"/>
+          <a:lstStyle/>
+          <a:p>
+            <a:pPr algn="ctr"/>
+            <a:r>
+              <a:rPr sz="2800" b="1">
+                <a:solidFill>
+                  <a:srgbClr val="0A7D5A"/>
+                </a:solidFill>
+              </a:rPr>
+              <a:t>▶  Vídeo de demo de EcoAlerta</a:t>
+            </a:r>
+          </a:p>
+          <a:p>
+            <a:pPr algn="ctr">
+              <a:spcBef>
+                <a:spcPts val="1600"/>
+              </a:spcBef>
+            </a:pPr>
+            <a:r>
+              <a:rPr sz="1400">
+                <a:solidFill>
+                  <a:srgbClr val="1A1A1A"/>
+                </a:solidFill>
+              </a:rPr>
+              <a:t>Insertar aquí:  Insertar → Vídeo → Este dispositivo</a:t>
+            </a:r>
+          </a:p>
+          <a:p>
+            <a:pPr algn="ctr">
+              <a:spcBef>
+                <a:spcPts val="200"/>
+              </a:spcBef>
+            </a:pPr>
+            <a:r>
+              <a:rPr sz="1200" i="1">
+                <a:solidFill>
+                  <a:srgbClr val="555555"/>
+                </a:solidFill>
+              </a:rPr>
+              <a:t>(elige “incrustar”, no “enlazar”)</a:t>
+            </a:r>
+          </a:p>
+        </p:txBody>
+      </p:sp>
+      <p:sp>
+        <p:nvSpPr>
+          <p:cNvPr id="7" name="TextBox 6"/>
+          <p:cNvSpPr txBox="1"/>
+          <p:nvPr/>
+        </p:nvSpPr>
+        <p:spPr>
+          <a:xfrm>
+            <a:off x="2194560" y="5989320"/>
+            <a:ext cx="7799831" cy="365760"/>
           </a:xfrm>
           <a:prstGeom prst="rect">
             <a:avLst/>
           </a:prstGeom>
           <a:noFill/>
-          <a:ln/>
-        </p:spPr>
-        <p:txBody>
-          <a:bodyPr wrap="square" rtlCol="0" anchor="ctr"/>
-          <a:lstStyle/>
-          <a:p>
-            <a:pPr algn="ctr" indent="0" marL="0">
-              <a:buNone/>
-            </a:pPr>
-            <a:r>
-              <a:rPr lang="en-US" sz="1200" b="1" dirty="0">
-                <a:solidFill>
-                  <a:srgbClr val="0E3A36"/>
-                </a:solidFill>
-                <a:latin typeface="Calibri" pitchFamily="34" charset="0"/>
-                <a:ea typeface="Calibri" pitchFamily="34" charset="-122"/>
-                <a:cs typeface="Calibri" pitchFamily="34" charset="-120"/>
-              </a:rPr>
-              <a:t>Mapa público con marcadores por severidad</a:t>
-            </a:r>
-            <a:endParaRPr lang="en-US" sz="1200" dirty="0"/>
-          </a:p>
-        </p:txBody>
-      </p:sp>
-      <p:sp>
-        <p:nvSpPr>
-          <p:cNvPr id="9" name="Shape 6"/>
-          <p:cNvSpPr/>
-          <p:nvPr/>
-        </p:nvSpPr>
-        <p:spPr>
-          <a:xfrm>
-            <a:off x="6537960" y="1371600"/>
-            <a:ext cx="5458968" cy="2331720"/>
-          </a:xfrm>
-          <a:prstGeom prst="roundRect">
-            <a:avLst>
-              <a:gd name="adj" fmla="val 3137"/>
-            </a:avLst>
-          </a:prstGeom>
-          <a:solidFill>
-            <a:srgbClr val="FFFFFF"/>
-          </a:solidFill>
-          <a:ln w="12700">
-            <a:solidFill>
-              <a:srgbClr val="E0EBE7"/>
-            </a:solidFill>
-            <a:prstDash val="solid"/>
-          </a:ln>
-          <a:effectLst>
-            <a:outerShdw sx="100000" sy="100000" kx="0" ky="0" algn="bl" rotWithShape="0" blurRad="88900" dist="38100" dir="8100000">
-              <a:srgbClr val="0E3A36">
-                <a:alpha val="16000"/>
-              </a:srgbClr>
-            </a:outerShdw>
-          </a:effectLst>
-        </p:spPr>
-      </p:sp>
-      <p:pic>
-        <p:nvPicPr>
-          <p:cNvPr id="10" name="Image 1" descr="/tmp/deck/assets/ui-crear-incidencia.png">    </p:cNvPr>
-          <p:cNvPicPr>
-            <a:picLocks noChangeAspect="1"/>
-          </p:cNvPicPr>
-          <p:nvPr/>
-        </p:nvPicPr>
-        <p:blipFill>
-          <a:blip r:embed="rId2"/>
-          <a:stretch>
-            <a:fillRect/>
-          </a:stretch>
-        </p:blipFill>
-        <p:spPr>
-          <a:xfrm>
-            <a:off x="7412435" y="1481328"/>
-            <a:ext cx="3710018" cy="1828800"/>
-          </a:xfrm>
-          <a:prstGeom prst="rect">
-            <a:avLst/>
-          </a:prstGeom>
-        </p:spPr>
-      </p:pic>
-      <p:sp>
-        <p:nvSpPr>
-          <p:cNvPr id="11" name="Text 7"/>
-          <p:cNvSpPr/>
-          <p:nvPr/>
-        </p:nvSpPr>
-        <p:spPr>
-          <a:xfrm>
-            <a:off x="6647688" y="3319272"/>
-            <a:ext cx="5239512" cy="329184"/>
-          </a:xfrm>
-          <a:prstGeom prst="rect">
-            <a:avLst/>
-          </a:prstGeom>
-          <a:noFill/>
-          <a:ln/>
-        </p:spPr>
-        <p:txBody>
-          <a:bodyPr wrap="square" rtlCol="0" anchor="ctr"/>
-          <a:lstStyle/>
-          <a:p>
-            <a:pPr algn="ctr" indent="0" marL="0">
-              <a:buNone/>
-            </a:pPr>
-            <a:r>
-              <a:rPr lang="en-US" sz="1200" b="1" dirty="0">
-                <a:solidFill>
-                  <a:srgbClr val="0E3A36"/>
-                </a:solidFill>
-                <a:latin typeface="Calibri" pitchFamily="34" charset="0"/>
-                <a:ea typeface="Calibri" pitchFamily="34" charset="-122"/>
-                <a:cs typeface="Calibri" pitchFamily="34" charset="-120"/>
-              </a:rPr>
-              <a:t>Reporte: categoría, severidad, foto y GPS</a:t>
-            </a:r>
-            <a:endParaRPr lang="en-US" sz="1200" dirty="0"/>
-          </a:p>
-        </p:txBody>
-      </p:sp>
-      <p:sp>
-        <p:nvSpPr>
-          <p:cNvPr id="12" name="Shape 8"/>
-          <p:cNvSpPr/>
-          <p:nvPr/>
-        </p:nvSpPr>
-        <p:spPr>
-          <a:xfrm>
-            <a:off x="548640" y="3995928"/>
-            <a:ext cx="5458968" cy="2331720"/>
-          </a:xfrm>
-          <a:prstGeom prst="roundRect">
-            <a:avLst>
-              <a:gd name="adj" fmla="val 3137"/>
-            </a:avLst>
-          </a:prstGeom>
-          <a:solidFill>
-            <a:srgbClr val="FFFFFF"/>
-          </a:solidFill>
-          <a:ln w="12700">
-            <a:solidFill>
-              <a:srgbClr val="E0EBE7"/>
-            </a:solidFill>
-            <a:prstDash val="solid"/>
-          </a:ln>
-          <a:effectLst>
-            <a:outerShdw sx="100000" sy="100000" kx="0" ky="0" algn="bl" rotWithShape="0" blurRad="88900" dist="38100" dir="8100000">
-              <a:srgbClr val="0E3A36">
-                <a:alpha val="16000"/>
-              </a:srgbClr>
-            </a:outerShdw>
-          </a:effectLst>
-        </p:spPr>
-      </p:sp>
-      <p:pic>
-        <p:nvPicPr>
-          <p:cNvPr id="13" name="Image 2" descr="/tmp/deck/assets/ui-detalle.png">    </p:cNvPr>
-          <p:cNvPicPr>
-            <a:picLocks noChangeAspect="1"/>
-          </p:cNvPicPr>
-          <p:nvPr/>
-        </p:nvPicPr>
-        <p:blipFill>
-          <a:blip r:embed="rId3"/>
-          <a:stretch>
-            <a:fillRect/>
-          </a:stretch>
-        </p:blipFill>
-        <p:spPr>
-          <a:xfrm>
-            <a:off x="1422144" y="4105656"/>
-            <a:ext cx="3711959" cy="1828800"/>
-          </a:xfrm>
-          <a:prstGeom prst="rect">
-            <a:avLst/>
-          </a:prstGeom>
-        </p:spPr>
-      </p:pic>
-      <p:sp>
-        <p:nvSpPr>
-          <p:cNvPr id="14" name="Text 9"/>
-          <p:cNvSpPr/>
-          <p:nvPr/>
-        </p:nvSpPr>
-        <p:spPr>
-          <a:xfrm>
-            <a:off x="658368" y="5943600"/>
-            <a:ext cx="5239512" cy="329184"/>
-          </a:xfrm>
-          <a:prstGeom prst="rect">
-            <a:avLst/>
-          </a:prstGeom>
-          <a:noFill/>
-          <a:ln/>
-        </p:spPr>
-        <p:txBody>
-          <a:bodyPr wrap="square" rtlCol="0" anchor="ctr"/>
-          <a:lstStyle/>
-          <a:p>
-            <a:pPr algn="ctr" indent="0" marL="0">
-              <a:buNone/>
-            </a:pPr>
-            <a:r>
-              <a:rPr lang="en-US" sz="1200" b="1" dirty="0">
-                <a:solidFill>
-                  <a:srgbClr val="0E3A36"/>
-                </a:solidFill>
-                <a:latin typeface="Calibri" pitchFamily="34" charset="0"/>
-                <a:ea typeface="Calibri" pitchFamily="34" charset="-122"/>
-                <a:cs typeface="Calibri" pitchFamily="34" charset="-120"/>
-              </a:rPr>
-              <a:t>Detalle: fotos, votos, comentarios e historial</a:t>
-            </a:r>
-            <a:endParaRPr lang="en-US" sz="1200" dirty="0"/>
-          </a:p>
-        </p:txBody>
-      </p:sp>
-      <p:sp>
-        <p:nvSpPr>
-          <p:cNvPr id="15" name="Shape 10"/>
-          <p:cNvSpPr/>
-          <p:nvPr/>
-        </p:nvSpPr>
-        <p:spPr>
-          <a:xfrm>
-            <a:off x="6537960" y="3995928"/>
-            <a:ext cx="5458968" cy="2331720"/>
-          </a:xfrm>
-          <a:prstGeom prst="roundRect">
-            <a:avLst>
-              <a:gd name="adj" fmla="val 3137"/>
-            </a:avLst>
-          </a:prstGeom>
-          <a:solidFill>
-            <a:srgbClr val="FFFFFF"/>
-          </a:solidFill>
-          <a:ln w="12700">
-            <a:solidFill>
-              <a:srgbClr val="E0EBE7"/>
-            </a:solidFill>
-            <a:prstDash val="solid"/>
-          </a:ln>
-          <a:effectLst>
-            <a:outerShdw sx="100000" sy="100000" kx="0" ky="0" algn="bl" rotWithShape="0" blurRad="88900" dist="38100" dir="8100000">
-              <a:srgbClr val="0E3A36">
-                <a:alpha val="16000"/>
-              </a:srgbClr>
-            </a:outerShdw>
-          </a:effectLst>
-        </p:spPr>
-      </p:sp>
-      <p:pic>
-        <p:nvPicPr>
-          <p:cNvPr id="16" name="Image 3" descr="/tmp/deck/assets/manual-admin-dashboard.png">    </p:cNvPr>
-          <p:cNvPicPr>
-            <a:picLocks noChangeAspect="1"/>
-          </p:cNvPicPr>
-          <p:nvPr/>
-        </p:nvPicPr>
-        <p:blipFill>
-          <a:blip r:embed="rId4"/>
-          <a:stretch>
-            <a:fillRect/>
-          </a:stretch>
-        </p:blipFill>
-        <p:spPr>
-          <a:xfrm>
-            <a:off x="7786987" y="4105656"/>
-            <a:ext cx="2960914" cy="1828800"/>
-          </a:xfrm>
-          <a:prstGeom prst="rect">
-            <a:avLst/>
-          </a:prstGeom>
-        </p:spPr>
-      </p:pic>
-      <p:sp>
-        <p:nvSpPr>
-          <p:cNvPr id="17" name="Text 11"/>
-          <p:cNvSpPr/>
-          <p:nvPr/>
-        </p:nvSpPr>
-        <p:spPr>
-          <a:xfrm>
-            <a:off x="6647688" y="5943600"/>
-            <a:ext cx="5239512" cy="329184"/>
-          </a:xfrm>
-          <a:prstGeom prst="rect">
-            <a:avLst/>
-          </a:prstGeom>
-          <a:noFill/>
-          <a:ln/>
-        </p:spPr>
-        <p:txBody>
-          <a:bodyPr wrap="square" rtlCol="0" anchor="ctr"/>
-          <a:lstStyle/>
-          <a:p>
-            <a:pPr algn="ctr" indent="0" marL="0">
-              <a:buNone/>
-            </a:pPr>
-            <a:r>
-              <a:rPr lang="en-US" sz="1200" b="1" dirty="0">
-                <a:solidFill>
-                  <a:srgbClr val="0E3A36"/>
-                </a:solidFill>
-                <a:latin typeface="Calibri" pitchFamily="34" charset="0"/>
-                <a:ea typeface="Calibri" pitchFamily="34" charset="-122"/>
-                <a:cs typeface="Calibri" pitchFamily="34" charset="-120"/>
-              </a:rPr>
-              <a:t>Panel de administración con estadísticas</a:t>
-            </a:r>
-            <a:endParaRPr lang="en-US" sz="1200" dirty="0"/>
+        </p:spPr>
+        <p:txBody>
+          <a:bodyPr wrap="square">
+            <a:spAutoFit/>
+          </a:bodyPr>
+          <a:lstStyle/>
+          <a:p>
+            <a:pPr algn="ctr"/>
+            <a:r>
+              <a:rPr sz="1100" i="1">
+                <a:solidFill>
+                  <a:srgbClr val="555555"/>
+                </a:solidFill>
+              </a:rPr>
+              <a:t>Recorrido ~75 s: reporte en móvil → mapa → panel admin → notificación</a:t>
+            </a:r>
           </a:p>
         </p:txBody>
       </p:sp>

</xml_diff>